<commit_message>
Keep sequence self-loops inside groups and clear of following labels
</commit_message>
<xml_diff>
--- a/catalog/relations/templates/rel_sequence_3_8_lr.pptx
+++ b/catalog/relations/templates/rel_sequence_3_8_lr.pptx
@@ -4035,7 +4035,7 @@
         <p:spPr>
           <a:xfrm>
             <a:off x="731520" y="2971800"/>
-            <a:ext cx="10698480" cy="283464"/>
+            <a:ext cx="10698480" cy="237744"/>
           </a:xfrm>
           <a:prstGeom prst="rect">
             <a:avLst/>
@@ -4200,8 +4200,8 @@
         </p:nvSpPr>
         <p:spPr>
           <a:xfrm>
-            <a:off x="731520" y="3335274"/>
-            <a:ext cx="10698480" cy="283464"/>
+            <a:off x="731520" y="3328416"/>
+            <a:ext cx="10698480" cy="237744"/>
           </a:xfrm>
           <a:prstGeom prst="rect">
             <a:avLst/>
@@ -4257,7 +4257,7 @@
         </p:nvCxnSpPr>
         <p:spPr>
           <a:xfrm>
-            <a:off x="914400" y="3646170"/>
+            <a:off x="914400" y="3639312"/>
             <a:ext cx="10058400" cy="0"/>
           </a:xfrm>
           <a:prstGeom prst="line">
@@ -4293,7 +4293,7 @@
         </p:nvCxnSpPr>
         <p:spPr>
           <a:xfrm>
-            <a:off x="914400" y="3646170"/>
+            <a:off x="914400" y="3639312"/>
             <a:ext cx="10058400" cy="0"/>
           </a:xfrm>
           <a:prstGeom prst="line">
@@ -4329,7 +4329,7 @@
         </p:nvCxnSpPr>
         <p:spPr>
           <a:xfrm>
-            <a:off x="914400" y="3646170"/>
+            <a:off x="914400" y="3639312"/>
             <a:ext cx="10058400" cy="0"/>
           </a:xfrm>
           <a:prstGeom prst="line">
@@ -4366,8 +4366,8 @@
         </p:nvSpPr>
         <p:spPr>
           <a:xfrm>
-            <a:off x="731520" y="3698748"/>
-            <a:ext cx="10698480" cy="283464"/>
+            <a:off x="731520" y="3685032"/>
+            <a:ext cx="10698480" cy="237744"/>
           </a:xfrm>
           <a:prstGeom prst="rect">
             <a:avLst/>
@@ -4423,7 +4423,7 @@
         </p:nvCxnSpPr>
         <p:spPr>
           <a:xfrm>
-            <a:off x="914400" y="4009644"/>
+            <a:off x="914400" y="3995928"/>
             <a:ext cx="10058400" cy="0"/>
           </a:xfrm>
           <a:prstGeom prst="line">
@@ -4459,7 +4459,7 @@
         </p:nvCxnSpPr>
         <p:spPr>
           <a:xfrm>
-            <a:off x="914400" y="4009644"/>
+            <a:off x="914400" y="3995928"/>
             <a:ext cx="10058400" cy="0"/>
           </a:xfrm>
           <a:prstGeom prst="line">
@@ -4495,7 +4495,7 @@
         </p:nvCxnSpPr>
         <p:spPr>
           <a:xfrm>
-            <a:off x="914400" y="4009644"/>
+            <a:off x="914400" y="3995928"/>
             <a:ext cx="10058400" cy="0"/>
           </a:xfrm>
           <a:prstGeom prst="line">
@@ -4532,8 +4532,8 @@
         </p:nvSpPr>
         <p:spPr>
           <a:xfrm>
-            <a:off x="731520" y="4062222"/>
-            <a:ext cx="10698480" cy="283464"/>
+            <a:off x="731520" y="4041648"/>
+            <a:ext cx="10698480" cy="237744"/>
           </a:xfrm>
           <a:prstGeom prst="rect">
             <a:avLst/>
@@ -4589,7 +4589,7 @@
         </p:nvCxnSpPr>
         <p:spPr>
           <a:xfrm>
-            <a:off x="914400" y="4373118"/>
+            <a:off x="914400" y="4352544"/>
             <a:ext cx="10058400" cy="0"/>
           </a:xfrm>
           <a:prstGeom prst="line">
@@ -4625,7 +4625,7 @@
         </p:nvCxnSpPr>
         <p:spPr>
           <a:xfrm>
-            <a:off x="914400" y="4373118"/>
+            <a:off x="914400" y="4352544"/>
             <a:ext cx="10058400" cy="0"/>
           </a:xfrm>
           <a:prstGeom prst="line">
@@ -4661,7 +4661,7 @@
         </p:nvCxnSpPr>
         <p:spPr>
           <a:xfrm>
-            <a:off x="914400" y="4373118"/>
+            <a:off x="914400" y="4352544"/>
             <a:ext cx="10058400" cy="0"/>
           </a:xfrm>
           <a:prstGeom prst="line">
@@ -4698,8 +4698,8 @@
         </p:nvSpPr>
         <p:spPr>
           <a:xfrm>
-            <a:off x="731520" y="4425696"/>
-            <a:ext cx="10698480" cy="283464"/>
+            <a:off x="731520" y="4398264"/>
+            <a:ext cx="10698480" cy="237744"/>
           </a:xfrm>
           <a:prstGeom prst="rect">
             <a:avLst/>
@@ -4755,7 +4755,7 @@
         </p:nvCxnSpPr>
         <p:spPr>
           <a:xfrm>
-            <a:off x="914400" y="4736592"/>
+            <a:off x="914400" y="4709160"/>
             <a:ext cx="10058400" cy="0"/>
           </a:xfrm>
           <a:prstGeom prst="line">
@@ -4791,7 +4791,7 @@
         </p:nvCxnSpPr>
         <p:spPr>
           <a:xfrm>
-            <a:off x="914400" y="4736592"/>
+            <a:off x="914400" y="4709160"/>
             <a:ext cx="10058400" cy="0"/>
           </a:xfrm>
           <a:prstGeom prst="line">
@@ -4827,7 +4827,7 @@
         </p:nvCxnSpPr>
         <p:spPr>
           <a:xfrm>
-            <a:off x="914400" y="4736592"/>
+            <a:off x="914400" y="4709160"/>
             <a:ext cx="10058400" cy="0"/>
           </a:xfrm>
           <a:prstGeom prst="line">
@@ -4864,8 +4864,8 @@
         </p:nvSpPr>
         <p:spPr>
           <a:xfrm>
-            <a:off x="731520" y="4789170"/>
-            <a:ext cx="10698480" cy="283464"/>
+            <a:off x="731520" y="4754880"/>
+            <a:ext cx="10698480" cy="237744"/>
           </a:xfrm>
           <a:prstGeom prst="rect">
             <a:avLst/>
@@ -4921,7 +4921,7 @@
         </p:nvCxnSpPr>
         <p:spPr>
           <a:xfrm>
-            <a:off x="914400" y="5100066"/>
+            <a:off x="914400" y="5065776"/>
             <a:ext cx="10058400" cy="0"/>
           </a:xfrm>
           <a:prstGeom prst="line">
@@ -4957,7 +4957,7 @@
         </p:nvCxnSpPr>
         <p:spPr>
           <a:xfrm>
-            <a:off x="914400" y="5100066"/>
+            <a:off x="914400" y="5065776"/>
             <a:ext cx="10058400" cy="0"/>
           </a:xfrm>
           <a:prstGeom prst="line">
@@ -4993,7 +4993,7 @@
         </p:nvCxnSpPr>
         <p:spPr>
           <a:xfrm>
-            <a:off x="914400" y="5100066"/>
+            <a:off x="914400" y="5065776"/>
             <a:ext cx="10058400" cy="0"/>
           </a:xfrm>
           <a:prstGeom prst="line">
@@ -5030,8 +5030,8 @@
         </p:nvSpPr>
         <p:spPr>
           <a:xfrm>
-            <a:off x="731520" y="5152644"/>
-            <a:ext cx="10698480" cy="283464"/>
+            <a:off x="731520" y="5111496"/>
+            <a:ext cx="10698480" cy="237744"/>
           </a:xfrm>
           <a:prstGeom prst="rect">
             <a:avLst/>
@@ -5087,7 +5087,7 @@
         </p:nvCxnSpPr>
         <p:spPr>
           <a:xfrm>
-            <a:off x="914400" y="5463540"/>
+            <a:off x="914400" y="5422392"/>
             <a:ext cx="10058400" cy="0"/>
           </a:xfrm>
           <a:prstGeom prst="line">
@@ -5123,7 +5123,7 @@
         </p:nvCxnSpPr>
         <p:spPr>
           <a:xfrm>
-            <a:off x="914400" y="5463540"/>
+            <a:off x="914400" y="5422392"/>
             <a:ext cx="10058400" cy="0"/>
           </a:xfrm>
           <a:prstGeom prst="line">
@@ -5159,7 +5159,7 @@
         </p:nvCxnSpPr>
         <p:spPr>
           <a:xfrm>
-            <a:off x="914400" y="5463540"/>
+            <a:off x="914400" y="5422392"/>
             <a:ext cx="10058400" cy="0"/>
           </a:xfrm>
           <a:prstGeom prst="line">
@@ -5196,8 +5196,8 @@
         </p:nvSpPr>
         <p:spPr>
           <a:xfrm>
-            <a:off x="731520" y="5516118"/>
-            <a:ext cx="10698480" cy="283464"/>
+            <a:off x="731520" y="5468112"/>
+            <a:ext cx="10698480" cy="237744"/>
           </a:xfrm>
           <a:prstGeom prst="rect">
             <a:avLst/>
@@ -5253,7 +5253,7 @@
         </p:nvCxnSpPr>
         <p:spPr>
           <a:xfrm>
-            <a:off x="914400" y="5827014"/>
+            <a:off x="914400" y="5779008"/>
             <a:ext cx="10058400" cy="0"/>
           </a:xfrm>
           <a:prstGeom prst="line">
@@ -5289,7 +5289,7 @@
         </p:nvCxnSpPr>
         <p:spPr>
           <a:xfrm>
-            <a:off x="914400" y="5827014"/>
+            <a:off x="914400" y="5779008"/>
             <a:ext cx="10058400" cy="0"/>
           </a:xfrm>
           <a:prstGeom prst="line">
@@ -5325,7 +5325,7 @@
         </p:nvCxnSpPr>
         <p:spPr>
           <a:xfrm>
-            <a:off x="914400" y="5827014"/>
+            <a:off x="914400" y="5779008"/>
             <a:ext cx="10058400" cy="0"/>
           </a:xfrm>
           <a:prstGeom prst="line">

</xml_diff>